<commit_message>
Budget 2027 deck: fix PowerPoint repair error
Remove hidden think-cell OLE frame shared by duplicated slides, unique p14:creationId per slide,
update docProps/app.xml slide count/titles, [Content_Types].xml first in the package.

Co-Authored-By: Claude Opus 5.5 <noreply@anthropic.com>
Claude-Session: https://claude.ai/code/session_0142u1JgEJ5Z4iqbgjpLWfcB
</commit_message>
<xml_diff>
--- a/AdTech_Budget_2027.pptx
+++ b/AdTech_Budget_2027.pptx
@@ -15192,61 +15192,6 @@
           <a:chExt cx="0" cy="0"/>
         </a:xfrm>
       </p:grpSpPr>
-      <p:graphicFrame>
-        <p:nvGraphicFramePr>
-          <p:cNvPr id="6" name="think-cell data - do not delete" hidden="1"/>
-          <p:cNvGraphicFramePr>
-            <a:graphicFrameLocks noChangeAspect="1"/>
-          </p:cNvGraphicFramePr>
-          <p:nvPr>
-            <p:custDataLst>
-              <p:tags r:id="rId1"/>
-            </p:custDataLst>
-          </p:nvPr>
-        </p:nvGraphicFramePr>
-        <p:xfrm>
-          <a:off x="364175" y="829165"/>
-          <a:ext cx="1588" cy="1588"/>
-        </p:xfrm>
-        <a:graphic>
-          <a:graphicData uri="http://schemas.openxmlformats.org/presentationml/2006/ole">
-            <mc:AlternateContent xmlns:mc="http://schemas.openxmlformats.org/markup-compatibility/2006">
-              <mc:Choice xmlns:v="urn:schemas-microsoft-com:vml" Requires="v">
-                <p:oleObj name="Слайд think-cell" r:id="rId4" imgW="425" imgH="424" progId="TCLayout.ActiveDocument.1">
-                  <p:embed/>
-                </p:oleObj>
-              </mc:Choice>
-              <mc:Fallback>
-                <p:oleObj name="Слайд think-cell" r:id="rId4" imgW="425" imgH="424" progId="TCLayout.ActiveDocument.1">
-                  <p:embed/>
-                  <p:pic>
-                    <p:nvPicPr>
-                      <p:cNvPr id="6" name="think-cell data - do not delete" hidden="1"/>
-                      <p:cNvPicPr/>
-                      <p:nvPr/>
-                    </p:nvPicPr>
-                    <p:blipFill>
-                      <a:blip r:embed="rId5"/>
-                      <a:stretch>
-                        <a:fillRect/>
-                      </a:stretch>
-                    </p:blipFill>
-                    <p:spPr>
-                      <a:xfrm>
-                        <a:off x="364175" y="829165"/>
-                        <a:ext cx="1588" cy="1588"/>
-                      </a:xfrm>
-                      <a:prstGeom prst="rect">
-                        <a:avLst/>
-                      </a:prstGeom>
-                    </p:spPr>
-                  </p:pic>
-                </p:oleObj>
-              </mc:Fallback>
-            </mc:AlternateContent>
-          </a:graphicData>
-        </a:graphic>
-      </p:graphicFrame>
       <p:sp>
         <p:nvSpPr>
           <p:cNvPr id="3" name="Текст 2"/>
@@ -24830,7 +24775,7 @@
     </p:spTree>
     <p:extLst>
       <p:ext uri="{BB962C8B-B14F-4D97-AF65-F5344CB8AC3E}">
-        <p14:creationId xmlns:p14="http://schemas.microsoft.com/office/powerpoint/2010/main" val="1650885464"/>
+        <p14:creationId xmlns:p14="http://schemas.microsoft.com/office/powerpoint/2010/main" val="1116321858"/>
       </p:ext>
     </p:extLst>
   </p:cSld>
@@ -24857,61 +24802,6 @@
           <a:chExt cx="0" cy="0"/>
         </a:xfrm>
       </p:grpSpPr>
-      <p:graphicFrame>
-        <p:nvGraphicFramePr>
-          <p:cNvPr id="6" name="think-cell data - do not delete" hidden="1"/>
-          <p:cNvGraphicFramePr>
-            <a:graphicFrameLocks noChangeAspect="1"/>
-          </p:cNvGraphicFramePr>
-          <p:nvPr>
-            <p:custDataLst>
-              <p:tags r:id="rId1"/>
-            </p:custDataLst>
-          </p:nvPr>
-        </p:nvGraphicFramePr>
-        <p:xfrm>
-          <a:off x="364175" y="829165"/>
-          <a:ext cx="1588" cy="1588"/>
-        </p:xfrm>
-        <a:graphic>
-          <a:graphicData uri="http://schemas.openxmlformats.org/presentationml/2006/ole">
-            <mc:AlternateContent xmlns:mc="http://schemas.openxmlformats.org/markup-compatibility/2006">
-              <mc:Choice xmlns:v="urn:schemas-microsoft-com:vml" Requires="v">
-                <p:oleObj name="Слайд think-cell" r:id="rId4" imgW="425" imgH="424" progId="TCLayout.ActiveDocument.1">
-                  <p:embed/>
-                </p:oleObj>
-              </mc:Choice>
-              <mc:Fallback>
-                <p:oleObj name="Слайд think-cell" r:id="rId4" imgW="425" imgH="424" progId="TCLayout.ActiveDocument.1">
-                  <p:embed/>
-                  <p:pic>
-                    <p:nvPicPr>
-                      <p:cNvPr id="6" name="think-cell data - do not delete" hidden="1"/>
-                      <p:cNvPicPr/>
-                      <p:nvPr/>
-                    </p:nvPicPr>
-                    <p:blipFill>
-                      <a:blip r:embed="rId5"/>
-                      <a:stretch>
-                        <a:fillRect/>
-                      </a:stretch>
-                    </p:blipFill>
-                    <p:spPr>
-                      <a:xfrm>
-                        <a:off x="364175" y="829165"/>
-                        <a:ext cx="1588" cy="1588"/>
-                      </a:xfrm>
-                      <a:prstGeom prst="rect">
-                        <a:avLst/>
-                      </a:prstGeom>
-                    </p:spPr>
-                  </p:pic>
-                </p:oleObj>
-              </mc:Fallback>
-            </mc:AlternateContent>
-          </a:graphicData>
-        </a:graphic>
-      </p:graphicFrame>
       <p:sp>
         <p:nvSpPr>
           <p:cNvPr id="3" name="Текст 2"/>
@@ -28715,7 +28605,7 @@
     </p:spTree>
     <p:extLst>
       <p:ext uri="{BB962C8B-B14F-4D97-AF65-F5344CB8AC3E}">
-        <p14:creationId xmlns:p14="http://schemas.microsoft.com/office/powerpoint/2010/main" val="1650885464"/>
+        <p14:creationId xmlns:p14="http://schemas.microsoft.com/office/powerpoint/2010/main" val="1014564736"/>
       </p:ext>
     </p:extLst>
   </p:cSld>
@@ -28742,61 +28632,6 @@
           <a:chExt cx="0" cy="0"/>
         </a:xfrm>
       </p:grpSpPr>
-      <p:graphicFrame>
-        <p:nvGraphicFramePr>
-          <p:cNvPr id="6" name="think-cell data - do not delete" hidden="1"/>
-          <p:cNvGraphicFramePr>
-            <a:graphicFrameLocks noChangeAspect="1"/>
-          </p:cNvGraphicFramePr>
-          <p:nvPr>
-            <p:custDataLst>
-              <p:tags r:id="rId1"/>
-            </p:custDataLst>
-          </p:nvPr>
-        </p:nvGraphicFramePr>
-        <p:xfrm>
-          <a:off x="364175" y="829165"/>
-          <a:ext cx="1588" cy="1588"/>
-        </p:xfrm>
-        <a:graphic>
-          <a:graphicData uri="http://schemas.openxmlformats.org/presentationml/2006/ole">
-            <mc:AlternateContent xmlns:mc="http://schemas.openxmlformats.org/markup-compatibility/2006">
-              <mc:Choice xmlns:v="urn:schemas-microsoft-com:vml" Requires="v">
-                <p:oleObj name="Слайд think-cell" r:id="rId4" imgW="425" imgH="424" progId="TCLayout.ActiveDocument.1">
-                  <p:embed/>
-                </p:oleObj>
-              </mc:Choice>
-              <mc:Fallback>
-                <p:oleObj name="Слайд think-cell" r:id="rId4" imgW="425" imgH="424" progId="TCLayout.ActiveDocument.1">
-                  <p:embed/>
-                  <p:pic>
-                    <p:nvPicPr>
-                      <p:cNvPr id="6" name="think-cell data - do not delete" hidden="1"/>
-                      <p:cNvPicPr/>
-                      <p:nvPr/>
-                    </p:nvPicPr>
-                    <p:blipFill>
-                      <a:blip r:embed="rId5"/>
-                      <a:stretch>
-                        <a:fillRect/>
-                      </a:stretch>
-                    </p:blipFill>
-                    <p:spPr>
-                      <a:xfrm>
-                        <a:off x="364175" y="829165"/>
-                        <a:ext cx="1588" cy="1588"/>
-                      </a:xfrm>
-                      <a:prstGeom prst="rect">
-                        <a:avLst/>
-                      </a:prstGeom>
-                    </p:spPr>
-                  </p:pic>
-                </p:oleObj>
-              </mc:Fallback>
-            </mc:AlternateContent>
-          </a:graphicData>
-        </a:graphic>
-      </p:graphicFrame>
       <p:sp>
         <p:nvSpPr>
           <p:cNvPr id="3" name="Текст 2"/>
@@ -39593,7 +39428,7 @@
     </p:spTree>
     <p:extLst>
       <p:ext uri="{BB962C8B-B14F-4D97-AF65-F5344CB8AC3E}">
-        <p14:creationId xmlns:p14="http://schemas.microsoft.com/office/powerpoint/2010/main" val="1650885464"/>
+        <p14:creationId xmlns:p14="http://schemas.microsoft.com/office/powerpoint/2010/main" val="1085449051"/>
       </p:ext>
     </p:extLst>
   </p:cSld>
@@ -39620,61 +39455,6 @@
           <a:chExt cx="0" cy="0"/>
         </a:xfrm>
       </p:grpSpPr>
-      <p:graphicFrame>
-        <p:nvGraphicFramePr>
-          <p:cNvPr id="6" name="think-cell data - do not delete" hidden="1"/>
-          <p:cNvGraphicFramePr>
-            <a:graphicFrameLocks noChangeAspect="1"/>
-          </p:cNvGraphicFramePr>
-          <p:nvPr>
-            <p:custDataLst>
-              <p:tags r:id="rId1"/>
-            </p:custDataLst>
-          </p:nvPr>
-        </p:nvGraphicFramePr>
-        <p:xfrm>
-          <a:off x="364175" y="829165"/>
-          <a:ext cx="1588" cy="1588"/>
-        </p:xfrm>
-        <a:graphic>
-          <a:graphicData uri="http://schemas.openxmlformats.org/presentationml/2006/ole">
-            <mc:AlternateContent xmlns:mc="http://schemas.openxmlformats.org/markup-compatibility/2006">
-              <mc:Choice xmlns:v="urn:schemas-microsoft-com:vml" Requires="v">
-                <p:oleObj name="Слайд think-cell" r:id="rId4" imgW="425" imgH="424" progId="TCLayout.ActiveDocument.1">
-                  <p:embed/>
-                </p:oleObj>
-              </mc:Choice>
-              <mc:Fallback>
-                <p:oleObj name="Слайд think-cell" r:id="rId4" imgW="425" imgH="424" progId="TCLayout.ActiveDocument.1">
-                  <p:embed/>
-                  <p:pic>
-                    <p:nvPicPr>
-                      <p:cNvPr id="6" name="think-cell data - do not delete" hidden="1"/>
-                      <p:cNvPicPr/>
-                      <p:nvPr/>
-                    </p:nvPicPr>
-                    <p:blipFill>
-                      <a:blip r:embed="rId5"/>
-                      <a:stretch>
-                        <a:fillRect/>
-                      </a:stretch>
-                    </p:blipFill>
-                    <p:spPr>
-                      <a:xfrm>
-                        <a:off x="364175" y="829165"/>
-                        <a:ext cx="1588" cy="1588"/>
-                      </a:xfrm>
-                      <a:prstGeom prst="rect">
-                        <a:avLst/>
-                      </a:prstGeom>
-                    </p:spPr>
-                  </p:pic>
-                </p:oleObj>
-              </mc:Fallback>
-            </mc:AlternateContent>
-          </a:graphicData>
-        </a:graphic>
-      </p:graphicFrame>
       <p:sp>
         <p:nvSpPr>
           <p:cNvPr id="3" name="Текст 2"/>
@@ -44000,7 +43780,7 @@
     </p:spTree>
     <p:extLst>
       <p:ext uri="{BB962C8B-B14F-4D97-AF65-F5344CB8AC3E}">
-        <p14:creationId xmlns:p14="http://schemas.microsoft.com/office/powerpoint/2010/main" val="1650885464"/>
+        <p14:creationId xmlns:p14="http://schemas.microsoft.com/office/powerpoint/2010/main" val="1498272094"/>
       </p:ext>
     </p:extLst>
   </p:cSld>
@@ -44027,61 +43807,6 @@
           <a:chExt cx="0" cy="0"/>
         </a:xfrm>
       </p:grpSpPr>
-      <p:graphicFrame>
-        <p:nvGraphicFramePr>
-          <p:cNvPr id="6" name="think-cell data - do not delete" hidden="1"/>
-          <p:cNvGraphicFramePr>
-            <a:graphicFrameLocks noChangeAspect="1"/>
-          </p:cNvGraphicFramePr>
-          <p:nvPr>
-            <p:custDataLst>
-              <p:tags r:id="rId1"/>
-            </p:custDataLst>
-          </p:nvPr>
-        </p:nvGraphicFramePr>
-        <p:xfrm>
-          <a:off x="364175" y="829165"/>
-          <a:ext cx="1588" cy="1588"/>
-        </p:xfrm>
-        <a:graphic>
-          <a:graphicData uri="http://schemas.openxmlformats.org/presentationml/2006/ole">
-            <mc:AlternateContent xmlns:mc="http://schemas.openxmlformats.org/markup-compatibility/2006">
-              <mc:Choice xmlns:v="urn:schemas-microsoft-com:vml" Requires="v">
-                <p:oleObj name="Слайд think-cell" r:id="rId4" imgW="425" imgH="424" progId="TCLayout.ActiveDocument.1">
-                  <p:embed/>
-                </p:oleObj>
-              </mc:Choice>
-              <mc:Fallback>
-                <p:oleObj name="Слайд think-cell" r:id="rId4" imgW="425" imgH="424" progId="TCLayout.ActiveDocument.1">
-                  <p:embed/>
-                  <p:pic>
-                    <p:nvPicPr>
-                      <p:cNvPr id="6" name="think-cell data - do not delete" hidden="1"/>
-                      <p:cNvPicPr/>
-                      <p:nvPr/>
-                    </p:nvPicPr>
-                    <p:blipFill>
-                      <a:blip r:embed="rId5"/>
-                      <a:stretch>
-                        <a:fillRect/>
-                      </a:stretch>
-                    </p:blipFill>
-                    <p:spPr>
-                      <a:xfrm>
-                        <a:off x="364175" y="829165"/>
-                        <a:ext cx="1588" cy="1588"/>
-                      </a:xfrm>
-                      <a:prstGeom prst="rect">
-                        <a:avLst/>
-                      </a:prstGeom>
-                    </p:spPr>
-                  </p:pic>
-                </p:oleObj>
-              </mc:Fallback>
-            </mc:AlternateContent>
-          </a:graphicData>
-        </a:graphic>
-      </p:graphicFrame>
       <p:sp>
         <p:nvSpPr>
           <p:cNvPr id="3" name="Текст 2"/>
@@ -53663,7 +53388,7 @@
     </p:spTree>
     <p:extLst>
       <p:ext uri="{BB962C8B-B14F-4D97-AF65-F5344CB8AC3E}">
-        <p14:creationId xmlns:p14="http://schemas.microsoft.com/office/powerpoint/2010/main" val="1650885464"/>
+        <p14:creationId xmlns:p14="http://schemas.microsoft.com/office/powerpoint/2010/main" val="1995405996"/>
       </p:ext>
     </p:extLst>
   </p:cSld>
@@ -53694,12 +53419,6 @@
 <file path=ppt/tags/tag4.xml><?xml version="1.0" encoding="utf-8"?>
 <p:tagLst xmlns:a="http://schemas.openxmlformats.org/drawingml/2006/main" xmlns:r="http://schemas.openxmlformats.org/officeDocument/2006/relationships" xmlns:p="http://schemas.openxmlformats.org/presentationml/2006/main">
   <p:tag name="THINKCELLSHAPEDONOTDELETE" val="tQsaBMu5Y9A2PtCcQK8SQlQ"/>
-</p:tagLst>
-</file>
-
-<file path=ppt/tags/tag5.xml><?xml version="1.0" encoding="utf-8"?>
-<p:tagLst xmlns:a="http://schemas.openxmlformats.org/drawingml/2006/main" xmlns:r="http://schemas.openxmlformats.org/officeDocument/2006/relationships" xmlns:p="http://schemas.openxmlformats.org/presentationml/2006/main">
-  <p:tag name="THINKCELLSHAPEDONOTDELETE" val="thinkcellActiveDocDoNotDelete"/>
 </p:tagLst>
 </file>
 

</xml_diff>